<commit_message>
docs: deck v2 with icons as images (no Material Icons font needed) and tighter slide 5 text
Co-Authored-By: Claude Opus 5.5 <noreply@anthropic.com>
Claude-Session: https://claude.ai/code/session_014dbHyWLyFZuyPpAtd6zGSy
</commit_message>
<xml_diff>
--- a/docs/TalentScout_AI_presentation_v2.pptx
+++ b/docs/TalentScout_AI_presentation_v2.pptx
@@ -6599,6 +6599,7 @@
                 <a:buNone/>
               </a:pPr>
               <a:r>
+                <a:rPr/>
                 <a:t/>
               </a:r>
               <a:endParaRPr/>
@@ -6663,6 +6664,7 @@
                 <a:buNone/>
               </a:pPr>
               <a:r>
+                <a:rPr/>
                 <a:t/>
               </a:r>
               <a:endParaRPr/>
@@ -6706,6 +6708,7 @@
                 <a:buNone/>
               </a:pPr>
               <a:r>
+                <a:rPr/>
                 <a:t/>
               </a:r>
               <a:endParaRPr/>
@@ -6806,70 +6809,37 @@
                   <a:buNone/>
                 </a:pPr>
                 <a:r>
+                  <a:rPr/>
                   <a:t/>
                 </a:r>
                 <a:endParaRPr/>
               </a:p>
             </p:txBody>
           </p:sp>
-          <p:sp>
-            <p:nvSpPr>
-              <p:cNvPr id="64" name="Google Shape;64;p14"/>
-              <p:cNvSpPr txBox="1"/>
+          <p:pic>
+            <p:nvPicPr>
+              <p:cNvPr id="83" name="Picture 82" descr="icon_auto_awesome.png"/>
+              <p:cNvPicPr>
+                <a:picLocks noChangeAspect="1"/>
+              </p:cNvPicPr>
               <p:nvPr/>
-            </p:nvSpPr>
+            </p:nvPicPr>
+            <p:blipFill>
+              <a:blip r:embed="rId5"/>
+              <a:stretch>
+                <a:fillRect/>
+              </a:stretch>
+            </p:blipFill>
             <p:spPr>
               <a:xfrm>
-                <a:off x="0" y="20447"/>
-                <a:ext cx="342900" cy="342900"/>
+                <a:off x="78105" y="98552"/>
+                <a:ext cx="186690" cy="186690"/>
               </a:xfrm>
               <a:prstGeom prst="rect">
                 <a:avLst/>
               </a:prstGeom>
-              <a:noFill/>
-              <a:ln>
-                <a:noFill/>
-              </a:ln>
             </p:spPr>
-            <p:txBody>
-              <a:bodyPr anchorCtr="0" anchor="ctr" bIns="0" lIns="0" spcFirstLastPara="1" rIns="0" wrap="square" tIns="0">
-                <a:noAutofit/>
-              </a:bodyPr>
-              <a:lstStyle/>
-              <a:p>
-                <a:pPr indent="0" lvl="0" marL="0" rtl="0" algn="ctr">
-                  <a:spcBef>
-                    <a:spcPts val="0"/>
-                  </a:spcBef>
-                  <a:spcAft>
-                    <a:spcPts val="0"/>
-                  </a:spcAft>
-                  <a:buNone/>
-                </a:pPr>
-                <a:r>
-                  <a:rPr lang="en" sz="1400">
-                    <a:solidFill>
-                      <a:srgbClr val="7C3AED"/>
-                    </a:solidFill>
-                    <a:latin typeface="Material Icons"/>
-                    <a:ea typeface="Material Icons"/>
-                    <a:cs typeface="Material Icons"/>
-                    <a:sym typeface="Material Icons"/>
-                  </a:rPr>
-                  <a:t>auto_awesome</a:t>
-                </a:r>
-                <a:endParaRPr sz="1400">
-                  <a:solidFill>
-                    <a:srgbClr val="7C3AED"/>
-                  </a:solidFill>
-                  <a:latin typeface="Material Icons"/>
-                  <a:ea typeface="Material Icons"/>
-                  <a:cs typeface="Material Icons"/>
-                  <a:sym typeface="Material Icons"/>
-                </a:endParaRPr>
-              </a:p>
-            </p:txBody>
-          </p:sp>
+          </p:pic>
           <p:sp>
             <p:nvSpPr>
               <p:cNvPr id="65" name="Google Shape;65;p14"/>
@@ -7012,70 +6982,37 @@
                   <a:buNone/>
                 </a:pPr>
                 <a:r>
+                  <a:rPr/>
                   <a:t/>
                 </a:r>
                 <a:endParaRPr/>
               </a:p>
             </p:txBody>
           </p:sp>
-          <p:sp>
-            <p:nvSpPr>
-              <p:cNvPr id="68" name="Google Shape;68;p14"/>
-              <p:cNvSpPr txBox="1"/>
+          <p:pic>
+            <p:nvPicPr>
+              <p:cNvPr id="84" name="Picture 83" descr="icon_fact_check.png"/>
+              <p:cNvPicPr>
+                <a:picLocks noChangeAspect="1"/>
+              </p:cNvPicPr>
               <p:nvPr/>
-            </p:nvSpPr>
+            </p:nvPicPr>
+            <p:blipFill>
+              <a:blip r:embed="rId6"/>
+              <a:stretch>
+                <a:fillRect/>
+              </a:stretch>
+            </p:blipFill>
             <p:spPr>
               <a:xfrm>
-                <a:off x="0" y="20447"/>
-                <a:ext cx="342900" cy="342900"/>
+                <a:off x="78105" y="98552"/>
+                <a:ext cx="186690" cy="186690"/>
               </a:xfrm>
               <a:prstGeom prst="rect">
                 <a:avLst/>
               </a:prstGeom>
-              <a:noFill/>
-              <a:ln>
-                <a:noFill/>
-              </a:ln>
             </p:spPr>
-            <p:txBody>
-              <a:bodyPr anchorCtr="0" anchor="ctr" bIns="0" lIns="0" spcFirstLastPara="1" rIns="0" wrap="square" tIns="0">
-                <a:noAutofit/>
-              </a:bodyPr>
-              <a:lstStyle/>
-              <a:p>
-                <a:pPr indent="0" lvl="0" marL="0" rtl="0" algn="ctr">
-                  <a:spcBef>
-                    <a:spcPts val="0"/>
-                  </a:spcBef>
-                  <a:spcAft>
-                    <a:spcPts val="0"/>
-                  </a:spcAft>
-                  <a:buNone/>
-                </a:pPr>
-                <a:r>
-                  <a:rPr lang="en" sz="1400">
-                    <a:solidFill>
-                      <a:srgbClr val="7C3AED"/>
-                    </a:solidFill>
-                    <a:latin typeface="Material Icons"/>
-                    <a:ea typeface="Material Icons"/>
-                    <a:cs typeface="Material Icons"/>
-                    <a:sym typeface="Material Icons"/>
-                  </a:rPr>
-                  <a:t>fact_check</a:t>
-                </a:r>
-                <a:endParaRPr sz="1400">
-                  <a:solidFill>
-                    <a:srgbClr val="7C3AED"/>
-                  </a:solidFill>
-                  <a:latin typeface="Material Icons"/>
-                  <a:ea typeface="Material Icons"/>
-                  <a:cs typeface="Material Icons"/>
-                  <a:sym typeface="Material Icons"/>
-                </a:endParaRPr>
-              </a:p>
-            </p:txBody>
-          </p:sp>
+          </p:pic>
           <p:sp>
             <p:nvSpPr>
               <p:cNvPr id="69" name="Google Shape;69;p14"/>
@@ -7218,70 +7155,37 @@
                   <a:buNone/>
                 </a:pPr>
                 <a:r>
+                  <a:rPr/>
                   <a:t/>
                 </a:r>
                 <a:endParaRPr/>
               </a:p>
             </p:txBody>
           </p:sp>
-          <p:sp>
-            <p:nvSpPr>
-              <p:cNvPr id="72" name="Google Shape;72;p14"/>
-              <p:cNvSpPr txBox="1"/>
+          <p:pic>
+            <p:nvPicPr>
+              <p:cNvPr id="85" name="Picture 84" descr="icon_mark_email_read.png"/>
+              <p:cNvPicPr>
+                <a:picLocks noChangeAspect="1"/>
+              </p:cNvPicPr>
               <p:nvPr/>
-            </p:nvSpPr>
+            </p:nvPicPr>
+            <p:blipFill>
+              <a:blip r:embed="rId7"/>
+              <a:stretch>
+                <a:fillRect/>
+              </a:stretch>
+            </p:blipFill>
             <p:spPr>
               <a:xfrm>
-                <a:off x="0" y="20447"/>
-                <a:ext cx="342900" cy="342900"/>
+                <a:off x="78105" y="98552"/>
+                <a:ext cx="186690" cy="186690"/>
               </a:xfrm>
               <a:prstGeom prst="rect">
                 <a:avLst/>
               </a:prstGeom>
-              <a:noFill/>
-              <a:ln>
-                <a:noFill/>
-              </a:ln>
             </p:spPr>
-            <p:txBody>
-              <a:bodyPr anchorCtr="0" anchor="ctr" bIns="0" lIns="0" spcFirstLastPara="1" rIns="0" wrap="square" tIns="0">
-                <a:noAutofit/>
-              </a:bodyPr>
-              <a:lstStyle/>
-              <a:p>
-                <a:pPr indent="0" lvl="0" marL="0" rtl="0" algn="ctr">
-                  <a:spcBef>
-                    <a:spcPts val="0"/>
-                  </a:spcBef>
-                  <a:spcAft>
-                    <a:spcPts val="0"/>
-                  </a:spcAft>
-                  <a:buNone/>
-                </a:pPr>
-                <a:r>
-                  <a:rPr lang="en" sz="1400">
-                    <a:solidFill>
-                      <a:srgbClr val="7C3AED"/>
-                    </a:solidFill>
-                    <a:latin typeface="Material Icons"/>
-                    <a:ea typeface="Material Icons"/>
-                    <a:cs typeface="Material Icons"/>
-                    <a:sym typeface="Material Icons"/>
-                  </a:rPr>
-                  <a:t>mark_email_read</a:t>
-                </a:r>
-                <a:endParaRPr sz="1400">
-                  <a:solidFill>
-                    <a:srgbClr val="7C3AED"/>
-                  </a:solidFill>
-                  <a:latin typeface="Material Icons"/>
-                  <a:ea typeface="Material Icons"/>
-                  <a:cs typeface="Material Icons"/>
-                  <a:sym typeface="Material Icons"/>
-                </a:endParaRPr>
-              </a:p>
-            </p:txBody>
-          </p:sp>
+          </p:pic>
           <p:sp>
             <p:nvSpPr>
               <p:cNvPr id="73" name="Google Shape;73;p14"/>
@@ -7432,6 +7336,7 @@
                   <a:buNone/>
                 </a:pPr>
                 <a:r>
+                  <a:rPr/>
                   <a:t/>
                 </a:r>
                 <a:endParaRPr/>
@@ -7477,6 +7382,7 @@
                   <a:buNone/>
                 </a:pPr>
                 <a:r>
+                  <a:rPr/>
                   <a:t/>
                 </a:r>
                 <a:endParaRPr/>
@@ -7753,6 +7659,7 @@
               <a:buNone/>
             </a:pPr>
             <a:r>
+              <a:rPr/>
               <a:t/>
             </a:r>
             <a:endParaRPr/>
@@ -7862,6 +7769,7 @@
                 <a:buNone/>
               </a:pPr>
               <a:r>
+                <a:rPr/>
                 <a:t/>
               </a:r>
               <a:endParaRPr/>
@@ -7950,6 +7858,7 @@
                   <a:buNone/>
                 </a:pPr>
                 <a:r>
+                  <a:rPr/>
                   <a:t/>
                 </a:r>
                 <a:endParaRPr/>
@@ -8014,6 +7923,7 @@
                   <a:buNone/>
                 </a:pPr>
                 <a:r>
+                  <a:rPr/>
                   <a:t/>
                 </a:r>
                 <a:endParaRPr/>
@@ -8057,6 +7967,7 @@
                   <a:buNone/>
                 </a:pPr>
                 <a:r>
+                  <a:rPr/>
                   <a:t/>
                 </a:r>
                 <a:endParaRPr/>
@@ -8215,6 +8126,7 @@
                   <a:buNone/>
                 </a:pPr>
                 <a:r>
+                  <a:rPr/>
                   <a:t/>
                 </a:r>
                 <a:endParaRPr/>
@@ -8416,6 +8328,7 @@
                   <a:buNone/>
                 </a:pPr>
                 <a:r>
+                  <a:rPr/>
                   <a:t/>
                 </a:r>
                 <a:endParaRPr/>
@@ -8590,6 +8503,7 @@
                   <a:buNone/>
                 </a:pPr>
                 <a:r>
+                  <a:rPr/>
                   <a:t/>
                 </a:r>
                 <a:endParaRPr/>
@@ -8821,6 +8735,7 @@
                 <a:buNone/>
               </a:pPr>
               <a:r>
+                <a:rPr/>
                 <a:t/>
               </a:r>
               <a:endParaRPr/>
@@ -9327,6 +9242,7 @@
                 <a:buNone/>
               </a:pPr>
               <a:r>
+                <a:rPr/>
                 <a:t/>
               </a:r>
               <a:endParaRPr/>
@@ -9386,6 +9302,7 @@
                   <a:buNone/>
                 </a:pPr>
                 <a:r>
+                  <a:rPr/>
                   <a:t/>
                 </a:r>
                 <a:endParaRPr/>
@@ -9450,6 +9367,7 @@
                   <a:buNone/>
                 </a:pPr>
                 <a:r>
+                  <a:rPr/>
                   <a:t/>
                 </a:r>
                 <a:endParaRPr/>
@@ -9493,6 +9411,7 @@
                   <a:buNone/>
                 </a:pPr>
                 <a:r>
+                  <a:rPr/>
                   <a:t/>
                 </a:r>
                 <a:endParaRPr/>
@@ -9719,6 +9638,7 @@
                 <a:buNone/>
               </a:pPr>
               <a:r>
+                <a:rPr/>
                 <a:t/>
               </a:r>
               <a:endParaRPr/>
@@ -9842,6 +9762,7 @@
                   <a:buNone/>
                 </a:pPr>
                 <a:r>
+                  <a:rPr/>
                   <a:t/>
                 </a:r>
                 <a:endParaRPr/>
@@ -9998,6 +9919,7 @@
                   <a:buNone/>
                 </a:pPr>
                 <a:r>
+                  <a:rPr/>
                   <a:t/>
                 </a:r>
                 <a:endParaRPr/>
@@ -10244,6 +10166,7 @@
                   <a:buNone/>
                 </a:pPr>
                 <a:r>
+                  <a:rPr/>
                   <a:t/>
                 </a:r>
                 <a:endParaRPr/>
@@ -10369,6 +10292,7 @@
                 <a:buNone/>
               </a:pPr>
               <a:r>
+                <a:rPr/>
                 <a:t/>
               </a:r>
               <a:endParaRPr/>
@@ -10484,70 +10408,37 @@
                   <a:buNone/>
                 </a:pPr>
                 <a:r>
+                  <a:rPr/>
                   <a:t/>
                 </a:r>
                 <a:endParaRPr/>
               </a:p>
             </p:txBody>
           </p:sp>
-          <p:sp>
-            <p:nvSpPr>
-              <p:cNvPr id="115" name="Google Shape;115;p15"/>
-              <p:cNvSpPr txBox="1"/>
+          <p:pic>
+            <p:nvPicPr>
+              <p:cNvPr id="127" name="Picture 126" descr="icon_warning_amber.png"/>
+              <p:cNvPicPr>
+                <a:picLocks noChangeAspect="1"/>
+              </p:cNvPicPr>
               <p:nvPr/>
-            </p:nvSpPr>
+            </p:nvPicPr>
+            <p:blipFill>
+              <a:blip r:embed="rId3"/>
+              <a:stretch>
+                <a:fillRect/>
+              </a:stretch>
+            </p:blipFill>
             <p:spPr>
               <a:xfrm>
-                <a:off x="0" y="20447"/>
-                <a:ext cx="266700" cy="266700"/>
+                <a:off x="40005" y="60452"/>
+                <a:ext cx="186690" cy="186690"/>
               </a:xfrm>
               <a:prstGeom prst="rect">
                 <a:avLst/>
               </a:prstGeom>
-              <a:noFill/>
-              <a:ln>
-                <a:noFill/>
-              </a:ln>
             </p:spPr>
-            <p:txBody>
-              <a:bodyPr anchorCtr="0" anchor="ctr" bIns="0" lIns="0" spcFirstLastPara="1" rIns="0" wrap="square" tIns="0">
-                <a:noAutofit/>
-              </a:bodyPr>
-              <a:lstStyle/>
-              <a:p>
-                <a:pPr indent="0" lvl="0" marL="0" rtl="0" algn="ctr">
-                  <a:spcBef>
-                    <a:spcPts val="0"/>
-                  </a:spcBef>
-                  <a:spcAft>
-                    <a:spcPts val="0"/>
-                  </a:spcAft>
-                  <a:buNone/>
-                </a:pPr>
-                <a:r>
-                  <a:rPr lang="en" sz="1400">
-                    <a:solidFill>
-                      <a:srgbClr val="7C3AED"/>
-                    </a:solidFill>
-                    <a:latin typeface="Material Icons"/>
-                    <a:ea typeface="Material Icons"/>
-                    <a:cs typeface="Material Icons"/>
-                    <a:sym typeface="Material Icons"/>
-                  </a:rPr>
-                  <a:t>warning_amber</a:t>
-                </a:r>
-                <a:endParaRPr sz="1400">
-                  <a:solidFill>
-                    <a:srgbClr val="7C3AED"/>
-                  </a:solidFill>
-                  <a:latin typeface="Material Icons"/>
-                  <a:ea typeface="Material Icons"/>
-                  <a:cs typeface="Material Icons"/>
-                  <a:sym typeface="Material Icons"/>
-                </a:endParaRPr>
-              </a:p>
-            </p:txBody>
-          </p:sp>
+          </p:pic>
           <p:sp>
             <p:nvSpPr>
               <p:cNvPr id="116" name="Google Shape;116;p15"/>
@@ -10690,70 +10581,37 @@
                   <a:buNone/>
                 </a:pPr>
                 <a:r>
+                  <a:rPr/>
                   <a:t/>
                 </a:r>
                 <a:endParaRPr/>
               </a:p>
             </p:txBody>
           </p:sp>
-          <p:sp>
-            <p:nvSpPr>
-              <p:cNvPr id="119" name="Google Shape;119;p15"/>
-              <p:cNvSpPr txBox="1"/>
+          <p:pic>
+            <p:nvPicPr>
+              <p:cNvPr id="128" name="Picture 127" descr="icon_schedule.png"/>
+              <p:cNvPicPr>
+                <a:picLocks noChangeAspect="1"/>
+              </p:cNvPicPr>
               <p:nvPr/>
-            </p:nvSpPr>
+            </p:nvPicPr>
+            <p:blipFill>
+              <a:blip r:embed="rId4"/>
+              <a:stretch>
+                <a:fillRect/>
+              </a:stretch>
+            </p:blipFill>
             <p:spPr>
               <a:xfrm>
-                <a:off x="0" y="20447"/>
-                <a:ext cx="266700" cy="266700"/>
+                <a:off x="40005" y="60452"/>
+                <a:ext cx="186690" cy="186690"/>
               </a:xfrm>
               <a:prstGeom prst="rect">
                 <a:avLst/>
               </a:prstGeom>
-              <a:noFill/>
-              <a:ln>
-                <a:noFill/>
-              </a:ln>
             </p:spPr>
-            <p:txBody>
-              <a:bodyPr anchorCtr="0" anchor="ctr" bIns="0" lIns="0" spcFirstLastPara="1" rIns="0" wrap="square" tIns="0">
-                <a:noAutofit/>
-              </a:bodyPr>
-              <a:lstStyle/>
-              <a:p>
-                <a:pPr indent="0" lvl="0" marL="0" rtl="0" algn="ctr">
-                  <a:spcBef>
-                    <a:spcPts val="0"/>
-                  </a:spcBef>
-                  <a:spcAft>
-                    <a:spcPts val="0"/>
-                  </a:spcAft>
-                  <a:buNone/>
-                </a:pPr>
-                <a:r>
-                  <a:rPr lang="en" sz="1400">
-                    <a:solidFill>
-                      <a:srgbClr val="7C3AED"/>
-                    </a:solidFill>
-                    <a:latin typeface="Material Icons"/>
-                    <a:ea typeface="Material Icons"/>
-                    <a:cs typeface="Material Icons"/>
-                    <a:sym typeface="Material Icons"/>
-                  </a:rPr>
-                  <a:t>schedule</a:t>
-                </a:r>
-                <a:endParaRPr sz="1400">
-                  <a:solidFill>
-                    <a:srgbClr val="7C3AED"/>
-                  </a:solidFill>
-                  <a:latin typeface="Material Icons"/>
-                  <a:ea typeface="Material Icons"/>
-                  <a:cs typeface="Material Icons"/>
-                  <a:sym typeface="Material Icons"/>
-                </a:endParaRPr>
-              </a:p>
-            </p:txBody>
-          </p:sp>
+          </p:pic>
           <p:sp>
             <p:nvSpPr>
               <p:cNvPr id="120" name="Google Shape;120;p15"/>
@@ -10932,6 +10790,7 @@
                   <a:buNone/>
                 </a:pPr>
                 <a:r>
+                  <a:rPr/>
                   <a:t/>
                 </a:r>
                 <a:endParaRPr/>
@@ -10975,6 +10834,7 @@
                   <a:buNone/>
                 </a:pPr>
                 <a:r>
+                  <a:rPr/>
                   <a:t/>
                 </a:r>
                 <a:endParaRPr/>
@@ -11193,6 +11053,7 @@
               <a:buNone/>
             </a:pPr>
             <a:r>
+              <a:rPr/>
               <a:t/>
             </a:r>
             <a:endParaRPr/>
@@ -11236,6 +11097,7 @@
               <a:buNone/>
             </a:pPr>
             <a:r>
+              <a:rPr/>
               <a:t/>
             </a:r>
             <a:endParaRPr/>
@@ -11322,6 +11184,7 @@
                 <a:buNone/>
               </a:pPr>
               <a:r>
+                <a:rPr/>
                 <a:t/>
               </a:r>
               <a:endParaRPr/>
@@ -11386,6 +11249,7 @@
                 <a:buNone/>
               </a:pPr>
               <a:r>
+                <a:rPr/>
                 <a:t/>
               </a:r>
               <a:endParaRPr/>
@@ -11429,6 +11293,7 @@
                 <a:buNone/>
               </a:pPr>
               <a:r>
+                <a:rPr/>
                 <a:t/>
               </a:r>
               <a:endParaRPr/>
@@ -11591,6 +11456,7 @@
                   <a:buNone/>
                 </a:pPr>
                 <a:r>
+                  <a:rPr/>
                   <a:t/>
                 </a:r>
                 <a:endParaRPr/>
@@ -11797,6 +11663,7 @@
                   <a:buNone/>
                 </a:pPr>
                 <a:r>
+                  <a:rPr/>
                   <a:t/>
                 </a:r>
                 <a:endParaRPr/>
@@ -12003,6 +11870,7 @@
                   <a:buNone/>
                 </a:pPr>
                 <a:r>
+                  <a:rPr/>
                   <a:t/>
                 </a:r>
                 <a:endParaRPr/>
@@ -12209,6 +12077,7 @@
                   <a:buNone/>
                 </a:pPr>
                 <a:r>
+                  <a:rPr/>
                   <a:t/>
                 </a:r>
                 <a:endParaRPr/>
@@ -12424,6 +12293,7 @@
                 <a:buNone/>
               </a:pPr>
               <a:r>
+                <a:rPr/>
                 <a:t/>
               </a:r>
               <a:endParaRPr/>
@@ -12469,6 +12339,7 @@
                 <a:buNone/>
               </a:pPr>
               <a:r>
+                <a:rPr/>
                 <a:t/>
               </a:r>
               <a:endParaRPr/>
@@ -12761,6 +12632,7 @@
                   <a:buNone/>
                 </a:pPr>
                 <a:r>
+                  <a:rPr/>
                   <a:t/>
                 </a:r>
                 <a:endParaRPr/>
@@ -12804,6 +12676,7 @@
                   <a:buNone/>
                 </a:pPr>
                 <a:r>
+                  <a:rPr/>
                   <a:t/>
                 </a:r>
                 <a:endParaRPr/>
@@ -13018,6 +12891,7 @@
                   <a:buNone/>
                 </a:pPr>
                 <a:r>
+                  <a:rPr/>
                   <a:t/>
                 </a:r>
                 <a:endParaRPr/>
@@ -13061,6 +12935,7 @@
                   <a:buNone/>
                 </a:pPr>
                 <a:r>
+                  <a:rPr/>
                   <a:t/>
                 </a:r>
                 <a:endParaRPr/>
@@ -13275,6 +13150,7 @@
                   <a:buNone/>
                 </a:pPr>
                 <a:r>
+                  <a:rPr/>
                   <a:t/>
                 </a:r>
                 <a:endParaRPr/>
@@ -13318,6 +13194,7 @@
                   <a:buNone/>
                 </a:pPr>
                 <a:r>
+                  <a:rPr/>
                   <a:t/>
                 </a:r>
                 <a:endParaRPr/>
@@ -13553,6 +13430,7 @@
                   <a:buNone/>
                 </a:pPr>
                 <a:r>
+                  <a:rPr/>
                   <a:t/>
                 </a:r>
                 <a:endParaRPr/>
@@ -13596,6 +13474,7 @@
                   <a:buNone/>
                 </a:pPr>
                 <a:r>
+                  <a:rPr/>
                   <a:t/>
                 </a:r>
                 <a:endParaRPr/>
@@ -13828,6 +13707,7 @@
                 <a:buNone/>
               </a:pPr>
               <a:r>
+                <a:rPr/>
                 <a:t/>
               </a:r>
               <a:endParaRPr/>
@@ -13887,6 +13767,7 @@
                   <a:buNone/>
                 </a:pPr>
                 <a:r>
+                  <a:rPr/>
                   <a:t/>
                 </a:r>
                 <a:endParaRPr/>
@@ -13951,6 +13832,7 @@
                   <a:buNone/>
                 </a:pPr>
                 <a:r>
+                  <a:rPr/>
                   <a:t/>
                 </a:r>
                 <a:endParaRPr/>
@@ -13994,6 +13876,7 @@
                   <a:buNone/>
                 </a:pPr>
                 <a:r>
+                  <a:rPr/>
                   <a:t/>
                 </a:r>
                 <a:endParaRPr/>
@@ -14305,6 +14188,7 @@
                 <a:buNone/>
               </a:pPr>
               <a:r>
+                <a:rPr/>
                 <a:t/>
               </a:r>
               <a:endParaRPr/>
@@ -14348,6 +14232,7 @@
                 <a:buNone/>
               </a:pPr>
               <a:r>
+                <a:rPr/>
                 <a:t/>
               </a:r>
               <a:endParaRPr/>
@@ -14567,6 +14452,7 @@
                 <a:buNone/>
               </a:pPr>
               <a:r>
+                <a:rPr/>
                 <a:t/>
               </a:r>
               <a:endParaRPr/>
@@ -14691,6 +14577,7 @@
                 <a:buNone/>
               </a:pPr>
               <a:r>
+                <a:rPr/>
                 <a:t/>
               </a:r>
               <a:endParaRPr/>
@@ -14734,6 +14621,7 @@
                 <a:buNone/>
               </a:pPr>
               <a:r>
+                <a:rPr/>
                 <a:t/>
               </a:r>
               <a:endParaRPr/>
@@ -14953,6 +14841,7 @@
                 <a:buNone/>
               </a:pPr>
               <a:r>
+                <a:rPr/>
                 <a:t/>
               </a:r>
               <a:endParaRPr/>
@@ -15096,6 +14985,7 @@
                 <a:buNone/>
               </a:pPr>
               <a:r>
+                <a:rPr/>
                 <a:t/>
               </a:r>
               <a:endParaRPr/>
@@ -15335,6 +15225,7 @@
                   <a:buNone/>
                 </a:pPr>
                 <a:r>
+                  <a:rPr/>
                   <a:t/>
                 </a:r>
                 <a:endParaRPr/>
@@ -15456,6 +15347,7 @@
                   <a:buNone/>
                 </a:pPr>
                 <a:r>
+                  <a:rPr/>
                   <a:t/>
                 </a:r>
                 <a:endParaRPr/>
@@ -15577,6 +15469,7 @@
                   <a:buNone/>
                 </a:pPr>
                 <a:r>
+                  <a:rPr/>
                   <a:t/>
                 </a:r>
                 <a:endParaRPr/>
@@ -15698,6 +15591,7 @@
                   <a:buNone/>
                 </a:pPr>
                 <a:r>
+                  <a:rPr/>
                   <a:t/>
                 </a:r>
                 <a:endParaRPr/>
@@ -15835,6 +15729,7 @@
                 <a:buNone/>
               </a:pPr>
               <a:r>
+                <a:rPr/>
                 <a:t/>
               </a:r>
               <a:endParaRPr/>
@@ -15878,6 +15773,7 @@
                 <a:buNone/>
               </a:pPr>
               <a:r>
+                <a:rPr/>
                 <a:t/>
               </a:r>
               <a:endParaRPr/>
@@ -16059,6 +15955,7 @@
                   <a:buNone/>
                 </a:pPr>
                 <a:r>
+                  <a:rPr/>
                   <a:t/>
                 </a:r>
                 <a:endParaRPr/>
@@ -16200,6 +16097,7 @@
                   <a:buNone/>
                 </a:pPr>
                 <a:r>
+                  <a:rPr/>
                   <a:t/>
                 </a:r>
                 <a:endParaRPr/>
@@ -16341,6 +16239,7 @@
                   <a:buNone/>
                 </a:pPr>
                 <a:r>
+                  <a:rPr/>
                   <a:t/>
                 </a:r>
                 <a:endParaRPr/>
@@ -16498,6 +16397,7 @@
                 <a:buNone/>
               </a:pPr>
               <a:r>
+                <a:rPr/>
                 <a:t/>
               </a:r>
               <a:endParaRPr/>
@@ -16541,6 +16441,7 @@
                 <a:buNone/>
               </a:pPr>
               <a:r>
+                <a:rPr/>
                 <a:t/>
               </a:r>
               <a:endParaRPr/>
@@ -16760,6 +16661,7 @@
                 <a:buNone/>
               </a:pPr>
               <a:r>
+                <a:rPr/>
                 <a:t/>
               </a:r>
               <a:endParaRPr/>
@@ -16884,6 +16786,7 @@
                 <a:buNone/>
               </a:pPr>
               <a:r>
+                <a:rPr/>
                 <a:t/>
               </a:r>
               <a:endParaRPr/>
@@ -16927,6 +16830,7 @@
                 <a:buNone/>
               </a:pPr>
               <a:r>
+                <a:rPr/>
                 <a:t/>
               </a:r>
               <a:endParaRPr/>
@@ -17148,6 +17052,7 @@
                 <a:buNone/>
               </a:pPr>
               <a:r>
+                <a:rPr/>
                 <a:t/>
               </a:r>
               <a:endParaRPr/>
@@ -17275,6 +17180,7 @@
               <a:buNone/>
             </a:pPr>
             <a:r>
+              <a:rPr/>
               <a:t/>
             </a:r>
             <a:endParaRPr/>
@@ -17334,6 +17240,7 @@
                 <a:buNone/>
               </a:pPr>
               <a:r>
+                <a:rPr/>
                 <a:t/>
               </a:r>
               <a:endParaRPr/>
@@ -17398,6 +17305,7 @@
                 <a:buNone/>
               </a:pPr>
               <a:r>
+                <a:rPr/>
                 <a:t/>
               </a:r>
               <a:endParaRPr/>
@@ -17441,6 +17349,7 @@
                 <a:buNone/>
               </a:pPr>
               <a:r>
+                <a:rPr/>
                 <a:t/>
               </a:r>
               <a:endParaRPr/>
@@ -17674,6 +17583,7 @@
                   <a:buNone/>
                 </a:pPr>
                 <a:r>
+                  <a:rPr/>
                   <a:t/>
                 </a:r>
                 <a:endParaRPr/>
@@ -17738,6 +17648,7 @@
                   <a:buNone/>
                 </a:pPr>
                 <a:r>
+                  <a:rPr/>
                   <a:t/>
                 </a:r>
                 <a:endParaRPr/>
@@ -17868,6 +17779,7 @@
                   <a:buNone/>
                 </a:pPr>
                 <a:r>
+                  <a:rPr/>
                   <a:t/>
                 </a:r>
                 <a:endParaRPr/>
@@ -17932,6 +17844,7 @@
                   <a:buNone/>
                 </a:pPr>
                 <a:r>
+                  <a:rPr/>
                   <a:t/>
                 </a:r>
                 <a:endParaRPr/>
@@ -17995,7 +17908,7 @@
                   <a:cs typeface="Inter"/>
                   <a:sym typeface="Inter"/>
                 </a:rPr>
-                <a:t> Invite sent via Brevo (demo mode delivers to the recruiter's inbox); rejections await approval.</a:t>
+                <a:t> Invite sent via Brevo (demo mode: recruiter's inbox); rejections await approval.</a:t>
               </a:r>
               <a:endParaRPr b="0" sz="902">
                 <a:solidFill>
@@ -18068,6 +17981,7 @@
                   <a:buNone/>
                 </a:pPr>
                 <a:r>
+                  <a:rPr/>
                   <a:t/>
                 </a:r>
                 <a:endParaRPr/>
@@ -18239,6 +18153,7 @@
                   <a:buNone/>
                 </a:pPr>
                 <a:r>
+                  <a:rPr/>
                   <a:t/>
                 </a:r>
                 <a:endParaRPr/>
@@ -18286,6 +18201,7 @@
                   <a:buNone/>
                 </a:pPr>
                 <a:r>
+                  <a:rPr/>
                   <a:t/>
                 </a:r>
                 <a:endParaRPr/>
@@ -18329,6 +18245,7 @@
                   <a:buNone/>
                 </a:pPr>
                 <a:r>
+                  <a:rPr/>
                   <a:t/>
                 </a:r>
                 <a:endParaRPr/>
@@ -18562,6 +18479,7 @@
                   <a:buNone/>
                 </a:pPr>
                 <a:r>
+                  <a:rPr/>
                   <a:t/>
                 </a:r>
                 <a:endParaRPr/>
@@ -18835,6 +18753,7 @@
                   <a:buNone/>
                 </a:pPr>
                 <a:r>
+                  <a:rPr/>
                   <a:t/>
                 </a:r>
                 <a:endParaRPr/>
@@ -18885,7 +18804,7 @@
                     <a:cs typeface="Inter SemiBold"/>
                     <a:sym typeface="Inter SemiBold"/>
                   </a:rPr>
-                  <a:t>OTHER CANDIDATES (3 APPLICANTS)</a:t>
+                  <a:t>OTHER CANDIDATES (3)</a:t>
                 </a:r>
                 <a:endParaRPr b="0" sz="900">
                   <a:solidFill>
@@ -18940,6 +18859,7 @@
                   <a:buNone/>
                 </a:pPr>
                 <a:r>
+                  <a:rPr/>
                   <a:t/>
                 </a:r>
                 <a:endParaRPr/>
@@ -19055,6 +18975,7 @@
                     <a:buNone/>
                   </a:pPr>
                   <a:r>
+                    <a:rPr/>
                     <a:t/>
                   </a:r>
                   <a:endParaRPr/>
@@ -19257,6 +19178,7 @@
                     <a:buNone/>
                   </a:pPr>
                   <a:r>
+                    <a:rPr/>
                     <a:t/>
                   </a:r>
                   <a:endParaRPr/>
@@ -19459,6 +19381,7 @@
                     <a:buNone/>
                   </a:pPr>
                   <a:r>
+                    <a:rPr/>
                     <a:t/>
                   </a:r>
                   <a:endParaRPr/>
@@ -19788,6 +19711,7 @@
                 <a:buNone/>
               </a:pPr>
               <a:r>
+                <a:rPr/>
                 <a:t/>
               </a:r>
               <a:endParaRPr/>
@@ -19852,6 +19776,7 @@
                 <a:buNone/>
               </a:pPr>
               <a:r>
+                <a:rPr/>
                 <a:t/>
               </a:r>
               <a:endParaRPr/>
@@ -19895,6 +19820,7 @@
                 <a:buNone/>
               </a:pPr>
               <a:r>
+                <a:rPr/>
                 <a:t/>
               </a:r>
               <a:endParaRPr/>
@@ -20624,6 +20550,7 @@
                   <a:buNone/>
                 </a:pPr>
                 <a:r>
+                  <a:rPr/>
                   <a:t/>
                 </a:r>
                 <a:endParaRPr/>
@@ -20806,6 +20733,7 @@
                   <a:buNone/>
                 </a:pPr>
                 <a:r>
+                  <a:rPr/>
                   <a:t/>
                 </a:r>
                 <a:endParaRPr/>
@@ -21040,6 +20968,7 @@
                 <a:buNone/>
               </a:pPr>
               <a:r>
+                <a:rPr/>
                 <a:t/>
               </a:r>
               <a:endParaRPr/>
@@ -21099,6 +21028,7 @@
                   <a:buNone/>
                 </a:pPr>
                 <a:r>
+                  <a:rPr/>
                   <a:t/>
                 </a:r>
                 <a:endParaRPr/>
@@ -21163,6 +21093,7 @@
                   <a:buNone/>
                 </a:pPr>
                 <a:r>
+                  <a:rPr/>
                   <a:t/>
                 </a:r>
                 <a:endParaRPr/>
@@ -21206,6 +21137,7 @@
                   <a:buNone/>
                 </a:pPr>
                 <a:r>
+                  <a:rPr/>
                   <a:t/>
                 </a:r>
                 <a:endParaRPr/>
@@ -21528,6 +21460,7 @@
                   <a:buNone/>
                 </a:pPr>
                 <a:r>
+                  <a:rPr/>
                   <a:t/>
                 </a:r>
                 <a:endParaRPr/>
@@ -21575,6 +21508,7 @@
                   <a:buNone/>
                 </a:pPr>
                 <a:r>
+                  <a:rPr/>
                   <a:t/>
                 </a:r>
                 <a:endParaRPr/>
@@ -21769,6 +21703,7 @@
                   <a:buNone/>
                 </a:pPr>
                 <a:r>
+                  <a:rPr/>
                   <a:t/>
                 </a:r>
                 <a:endParaRPr/>
@@ -21816,6 +21751,7 @@
                   <a:buNone/>
                 </a:pPr>
                 <a:r>
+                  <a:rPr/>
                   <a:t/>
                 </a:r>
                 <a:endParaRPr/>
@@ -22010,6 +21946,7 @@
                   <a:buNone/>
                 </a:pPr>
                 <a:r>
+                  <a:rPr/>
                   <a:t/>
                 </a:r>
                 <a:endParaRPr/>
@@ -22057,6 +21994,7 @@
                   <a:buNone/>
                 </a:pPr>
                 <a:r>
+                  <a:rPr/>
                   <a:t/>
                 </a:r>
                 <a:endParaRPr/>
@@ -22251,6 +22189,7 @@
                   <a:buNone/>
                 </a:pPr>
                 <a:r>
+                  <a:rPr/>
                   <a:t/>
                 </a:r>
                 <a:endParaRPr/>
@@ -22298,6 +22237,7 @@
                   <a:buNone/>
                 </a:pPr>
                 <a:r>
+                  <a:rPr/>
                   <a:t/>
                 </a:r>
                 <a:endParaRPr/>
@@ -22795,6 +22735,7 @@
                   <a:buNone/>
                 </a:pPr>
                 <a:r>
+                  <a:rPr/>
                   <a:t/>
                 </a:r>
                 <a:endParaRPr/>
@@ -22854,6 +22795,7 @@
                     <a:buNone/>
                   </a:pPr>
                   <a:r>
+                    <a:rPr/>
                     <a:t/>
                   </a:r>
                   <a:endParaRPr/>
@@ -22918,6 +22860,7 @@
                     <a:buNone/>
                   </a:pPr>
                   <a:r>
+                    <a:rPr/>
                     <a:t/>
                   </a:r>
                   <a:endParaRPr/>
@@ -23093,6 +23036,7 @@
                 <a:buNone/>
               </a:pPr>
               <a:r>
+                <a:rPr/>
                 <a:t/>
               </a:r>
               <a:endParaRPr/>
@@ -23152,6 +23096,7 @@
                   <a:buNone/>
                 </a:pPr>
                 <a:r>
+                  <a:rPr/>
                   <a:t/>
                 </a:r>
                 <a:endParaRPr/>
@@ -23216,6 +23161,7 @@
                   <a:buNone/>
                 </a:pPr>
                 <a:r>
+                  <a:rPr/>
                   <a:t/>
                 </a:r>
                 <a:endParaRPr/>
@@ -23259,6 +23205,7 @@
                   <a:buNone/>
                 </a:pPr>
                 <a:r>
+                  <a:rPr/>
                   <a:t/>
                 </a:r>
                 <a:endParaRPr/>
@@ -23499,6 +23446,7 @@
                   <a:buNone/>
                 </a:pPr>
                 <a:r>
+                  <a:rPr/>
                   <a:t/>
                 </a:r>
                 <a:endParaRPr/>
@@ -23572,6 +23520,7 @@
                       <a:buNone/>
                     </a:pPr>
                     <a:r>
+                      <a:rPr/>
                       <a:t/>
                     </a:r>
                     <a:endParaRPr/>
@@ -23636,6 +23585,7 @@
                       <a:buNone/>
                     </a:pPr>
                     <a:r>
+                      <a:rPr/>
                       <a:t/>
                     </a:r>
                     <a:endParaRPr/>
@@ -23801,6 +23751,7 @@
                   <a:buNone/>
                 </a:pPr>
                 <a:r>
+                  <a:rPr/>
                   <a:t/>
                 </a:r>
                 <a:endParaRPr/>
@@ -24059,6 +24010,7 @@
                   <a:buNone/>
                 </a:pPr>
                 <a:r>
+                  <a:rPr/>
                   <a:t/>
                 </a:r>
                 <a:endParaRPr/>
@@ -24132,6 +24084,7 @@
                       <a:buNone/>
                     </a:pPr>
                     <a:r>
+                      <a:rPr/>
                       <a:t/>
                     </a:r>
                     <a:endParaRPr/>
@@ -24196,6 +24149,7 @@
                       <a:buNone/>
                     </a:pPr>
                     <a:r>
+                      <a:rPr/>
                       <a:t/>
                     </a:r>
                     <a:endParaRPr/>
@@ -24361,6 +24315,7 @@
                   <a:buNone/>
                 </a:pPr>
                 <a:r>
+                  <a:rPr/>
                   <a:t/>
                 </a:r>
                 <a:endParaRPr/>
@@ -24631,6 +24586,7 @@
                   <a:buNone/>
                 </a:pPr>
                 <a:r>
+                  <a:rPr/>
                   <a:t/>
                 </a:r>
                 <a:endParaRPr/>
@@ -24704,6 +24660,7 @@
                       <a:buNone/>
                     </a:pPr>
                     <a:r>
+                      <a:rPr/>
                       <a:t/>
                     </a:r>
                     <a:endParaRPr/>
@@ -24768,6 +24725,7 @@
                       <a:buNone/>
                     </a:pPr>
                     <a:r>
+                      <a:rPr/>
                       <a:t/>
                     </a:r>
                     <a:endParaRPr/>
@@ -24933,6 +24891,7 @@
                   <a:buNone/>
                 </a:pPr>
                 <a:r>
+                  <a:rPr/>
                   <a:t/>
                 </a:r>
                 <a:endParaRPr/>
@@ -25221,6 +25180,7 @@
                 <a:buNone/>
               </a:pPr>
               <a:r>
+                <a:rPr/>
                 <a:t/>
               </a:r>
               <a:endParaRPr/>
@@ -25280,6 +25240,7 @@
                   <a:buNone/>
                 </a:pPr>
                 <a:r>
+                  <a:rPr/>
                   <a:t/>
                 </a:r>
                 <a:endParaRPr/>
@@ -25344,6 +25305,7 @@
                   <a:buNone/>
                 </a:pPr>
                 <a:r>
+                  <a:rPr/>
                   <a:t/>
                 </a:r>
                 <a:endParaRPr/>
@@ -25387,6 +25349,7 @@
                   <a:buNone/>
                 </a:pPr>
                 <a:r>
+                  <a:rPr/>
                   <a:t/>
                 </a:r>
                 <a:endParaRPr/>
@@ -25613,6 +25576,7 @@
                 <a:buNone/>
               </a:pPr>
               <a:r>
+                <a:rPr/>
                 <a:t/>
               </a:r>
               <a:endParaRPr/>
@@ -25685,6 +25649,7 @@
                 <a:buNone/>
               </a:pPr>
               <a:r>
+                <a:rPr/>
                 <a:t/>
               </a:r>
               <a:endParaRPr/>
@@ -25730,6 +25695,7 @@
                 <a:buNone/>
               </a:pPr>
               <a:r>
+                <a:rPr/>
                 <a:t/>
               </a:r>
               <a:endParaRPr/>
@@ -25775,6 +25741,7 @@
                 <a:buNone/>
               </a:pPr>
               <a:r>
+                <a:rPr/>
                 <a:t/>
               </a:r>
               <a:endParaRPr/>
@@ -25880,70 +25847,37 @@
                 <a:buNone/>
               </a:pPr>
               <a:r>
+                <a:rPr/>
                 <a:t/>
               </a:r>
               <a:endParaRPr/>
             </a:p>
           </p:txBody>
         </p:sp>
-        <p:sp>
-          <p:nvSpPr>
-            <p:cNvPr id="465" name="Google Shape;465;p22"/>
-            <p:cNvSpPr txBox="1"/>
+        <p:pic>
+          <p:nvPicPr>
+            <p:cNvPr id="495" name="Picture 494" descr="icon_fact_check.png"/>
+            <p:cNvPicPr>
+              <a:picLocks noChangeAspect="1"/>
+            </p:cNvPicPr>
             <p:nvPr/>
-          </p:nvSpPr>
+          </p:nvPicPr>
+          <p:blipFill>
+            <a:blip r:embed="rId3"/>
+            <a:stretch>
+              <a:fillRect/>
+            </a:stretch>
+          </p:blipFill>
           <p:spPr>
             <a:xfrm>
-              <a:off x="228600" y="252698"/>
-              <a:ext cx="419100" cy="419100"/>
+              <a:off x="328137" y="352235"/>
+              <a:ext cx="220027" cy="220027"/>
             </a:xfrm>
             <a:prstGeom prst="rect">
               <a:avLst/>
             </a:prstGeom>
-            <a:noFill/>
-            <a:ln>
-              <a:noFill/>
-            </a:ln>
           </p:spPr>
-          <p:txBody>
-            <a:bodyPr anchorCtr="0" anchor="ctr" bIns="0" lIns="0" spcFirstLastPara="1" rIns="0" wrap="square" tIns="0">
-              <a:noAutofit/>
-            </a:bodyPr>
-            <a:lstStyle/>
-            <a:p>
-              <a:pPr indent="0" lvl="0" marL="0" rtl="0" algn="ctr">
-                <a:spcBef>
-                  <a:spcPts val="0"/>
-                </a:spcBef>
-                <a:spcAft>
-                  <a:spcPts val="0"/>
-                </a:spcAft>
-                <a:buNone/>
-              </a:pPr>
-              <a:r>
-                <a:rPr lang="en" sz="1650">
-                  <a:solidFill>
-                    <a:srgbClr val="7C3AED"/>
-                  </a:solidFill>
-                  <a:latin typeface="Material Icons"/>
-                  <a:ea typeface="Material Icons"/>
-                  <a:cs typeface="Material Icons"/>
-                  <a:sym typeface="Material Icons"/>
-                </a:rPr>
-                <a:t>fact_check</a:t>
-              </a:r>
-              <a:endParaRPr sz="1650">
-                <a:solidFill>
-                  <a:srgbClr val="7C3AED"/>
-                </a:solidFill>
-                <a:latin typeface="Material Icons"/>
-                <a:ea typeface="Material Icons"/>
-                <a:cs typeface="Material Icons"/>
-                <a:sym typeface="Material Icons"/>
-              </a:endParaRPr>
-            </a:p>
-          </p:txBody>
-        </p:sp>
+        </p:pic>
         <p:sp>
           <p:nvSpPr>
             <p:cNvPr id="466" name="Google Shape;466;p22"/>
@@ -26120,6 +26054,7 @@
                 <a:buNone/>
               </a:pPr>
               <a:r>
+                <a:rPr/>
                 <a:t/>
               </a:r>
               <a:endParaRPr/>
@@ -26165,6 +26100,7 @@
                 <a:buNone/>
               </a:pPr>
               <a:r>
+                <a:rPr/>
                 <a:t/>
               </a:r>
               <a:endParaRPr/>
@@ -26210,6 +26146,7 @@
                 <a:buNone/>
               </a:pPr>
               <a:r>
+                <a:rPr/>
                 <a:t/>
               </a:r>
               <a:endParaRPr/>
@@ -26315,70 +26252,37 @@
                 <a:buNone/>
               </a:pPr>
               <a:r>
+                <a:rPr/>
                 <a:t/>
               </a:r>
               <a:endParaRPr/>
             </a:p>
           </p:txBody>
         </p:sp>
-        <p:sp>
-          <p:nvSpPr>
-            <p:cNvPr id="474" name="Google Shape;474;p22"/>
-            <p:cNvSpPr txBox="1"/>
+        <p:pic>
+          <p:nvPicPr>
+            <p:cNvPr id="496" name="Picture 495" descr="icon_balance.png"/>
+            <p:cNvPicPr>
+              <a:picLocks noChangeAspect="1"/>
+            </p:cNvPicPr>
             <p:nvPr/>
-          </p:nvSpPr>
+          </p:nvPicPr>
+          <p:blipFill>
+            <a:blip r:embed="rId4"/>
+            <a:stretch>
+              <a:fillRect/>
+            </a:stretch>
+          </p:blipFill>
           <p:spPr>
             <a:xfrm>
-              <a:off x="228600" y="252698"/>
-              <a:ext cx="419100" cy="419100"/>
+              <a:off x="328137" y="352235"/>
+              <a:ext cx="220027" cy="220027"/>
             </a:xfrm>
             <a:prstGeom prst="rect">
               <a:avLst/>
             </a:prstGeom>
-            <a:noFill/>
-            <a:ln>
-              <a:noFill/>
-            </a:ln>
           </p:spPr>
-          <p:txBody>
-            <a:bodyPr anchorCtr="0" anchor="ctr" bIns="0" lIns="0" spcFirstLastPara="1" rIns="0" wrap="square" tIns="0">
-              <a:noAutofit/>
-            </a:bodyPr>
-            <a:lstStyle/>
-            <a:p>
-              <a:pPr indent="0" lvl="0" marL="0" rtl="0" algn="ctr">
-                <a:spcBef>
-                  <a:spcPts val="0"/>
-                </a:spcBef>
-                <a:spcAft>
-                  <a:spcPts val="0"/>
-                </a:spcAft>
-                <a:buNone/>
-              </a:pPr>
-              <a:r>
-                <a:rPr lang="en" sz="1650">
-                  <a:solidFill>
-                    <a:srgbClr val="7C3AED"/>
-                  </a:solidFill>
-                  <a:latin typeface="Material Icons"/>
-                  <a:ea typeface="Material Icons"/>
-                  <a:cs typeface="Material Icons"/>
-                  <a:sym typeface="Material Icons"/>
-                </a:rPr>
-                <a:t>balance</a:t>
-              </a:r>
-              <a:endParaRPr sz="1650">
-                <a:solidFill>
-                  <a:srgbClr val="7C3AED"/>
-                </a:solidFill>
-                <a:latin typeface="Material Icons"/>
-                <a:ea typeface="Material Icons"/>
-                <a:cs typeface="Material Icons"/>
-                <a:sym typeface="Material Icons"/>
-              </a:endParaRPr>
-            </a:p>
-          </p:txBody>
-        </p:sp>
+        </p:pic>
         <p:sp>
           <p:nvSpPr>
             <p:cNvPr id="475" name="Google Shape;475;p22"/>
@@ -26555,6 +26459,7 @@
                 <a:buNone/>
               </a:pPr>
               <a:r>
+                <a:rPr/>
                 <a:t/>
               </a:r>
               <a:endParaRPr/>
@@ -26600,6 +26505,7 @@
                 <a:buNone/>
               </a:pPr>
               <a:r>
+                <a:rPr/>
                 <a:t/>
               </a:r>
               <a:endParaRPr/>
@@ -26645,6 +26551,7 @@
                 <a:buNone/>
               </a:pPr>
               <a:r>
+                <a:rPr/>
                 <a:t/>
               </a:r>
               <a:endParaRPr/>
@@ -26750,70 +26657,37 @@
                 <a:buNone/>
               </a:pPr>
               <a:r>
+                <a:rPr/>
                 <a:t/>
               </a:r>
               <a:endParaRPr/>
             </a:p>
           </p:txBody>
         </p:sp>
-        <p:sp>
-          <p:nvSpPr>
-            <p:cNvPr id="483" name="Google Shape;483;p22"/>
-            <p:cNvSpPr txBox="1"/>
+        <p:pic>
+          <p:nvPicPr>
+            <p:cNvPr id="497" name="Picture 496" descr="icon_touch_app.png"/>
+            <p:cNvPicPr>
+              <a:picLocks noChangeAspect="1"/>
+            </p:cNvPicPr>
             <p:nvPr/>
-          </p:nvSpPr>
+          </p:nvPicPr>
+          <p:blipFill>
+            <a:blip r:embed="rId5"/>
+            <a:stretch>
+              <a:fillRect/>
+            </a:stretch>
+          </p:blipFill>
           <p:spPr>
             <a:xfrm>
-              <a:off x="228600" y="252698"/>
-              <a:ext cx="419100" cy="419100"/>
+              <a:off x="328137" y="352235"/>
+              <a:ext cx="220027" cy="220027"/>
             </a:xfrm>
             <a:prstGeom prst="rect">
               <a:avLst/>
             </a:prstGeom>
-            <a:noFill/>
-            <a:ln>
-              <a:noFill/>
-            </a:ln>
           </p:spPr>
-          <p:txBody>
-            <a:bodyPr anchorCtr="0" anchor="ctr" bIns="0" lIns="0" spcFirstLastPara="1" rIns="0" wrap="square" tIns="0">
-              <a:noAutofit/>
-            </a:bodyPr>
-            <a:lstStyle/>
-            <a:p>
-              <a:pPr indent="0" lvl="0" marL="0" rtl="0" algn="ctr">
-                <a:spcBef>
-                  <a:spcPts val="0"/>
-                </a:spcBef>
-                <a:spcAft>
-                  <a:spcPts val="0"/>
-                </a:spcAft>
-                <a:buNone/>
-              </a:pPr>
-              <a:r>
-                <a:rPr lang="en" sz="1650">
-                  <a:solidFill>
-                    <a:srgbClr val="7C3AED"/>
-                  </a:solidFill>
-                  <a:latin typeface="Material Icons"/>
-                  <a:ea typeface="Material Icons"/>
-                  <a:cs typeface="Material Icons"/>
-                  <a:sym typeface="Material Icons"/>
-                </a:rPr>
-                <a:t>touch_app</a:t>
-              </a:r>
-              <a:endParaRPr sz="1650">
-                <a:solidFill>
-                  <a:srgbClr val="7C3AED"/>
-                </a:solidFill>
-                <a:latin typeface="Material Icons"/>
-                <a:ea typeface="Material Icons"/>
-                <a:cs typeface="Material Icons"/>
-                <a:sym typeface="Material Icons"/>
-              </a:endParaRPr>
-            </a:p>
-          </p:txBody>
-        </p:sp>
+        </p:pic>
         <p:sp>
           <p:nvSpPr>
             <p:cNvPr id="484" name="Google Shape;484;p22"/>
@@ -26990,6 +26864,7 @@
                 <a:buNone/>
               </a:pPr>
               <a:r>
+                <a:rPr/>
                 <a:t/>
               </a:r>
               <a:endParaRPr/>
@@ -27035,6 +26910,7 @@
                 <a:buNone/>
               </a:pPr>
               <a:r>
+                <a:rPr/>
                 <a:t/>
               </a:r>
               <a:endParaRPr/>
@@ -27080,6 +26956,7 @@
                 <a:buNone/>
               </a:pPr>
               <a:r>
+                <a:rPr/>
                 <a:t/>
               </a:r>
               <a:endParaRPr/>
@@ -27185,70 +27062,37 @@
                 <a:buNone/>
               </a:pPr>
               <a:r>
+                <a:rPr/>
                 <a:t/>
               </a:r>
               <a:endParaRPr/>
             </a:p>
           </p:txBody>
         </p:sp>
-        <p:sp>
-          <p:nvSpPr>
-            <p:cNvPr id="492" name="Google Shape;492;p22"/>
-            <p:cNvSpPr txBox="1"/>
+        <p:pic>
+          <p:nvPicPr>
+            <p:cNvPr id="498" name="Picture 497" descr="icon_verified_user.png"/>
+            <p:cNvPicPr>
+              <a:picLocks noChangeAspect="1"/>
+            </p:cNvPicPr>
             <p:nvPr/>
-          </p:nvSpPr>
+          </p:nvPicPr>
+          <p:blipFill>
+            <a:blip r:embed="rId6"/>
+            <a:stretch>
+              <a:fillRect/>
+            </a:stretch>
+          </p:blipFill>
           <p:spPr>
             <a:xfrm>
-              <a:off x="228600" y="252698"/>
-              <a:ext cx="419100" cy="419100"/>
+              <a:off x="328137" y="352235"/>
+              <a:ext cx="220027" cy="220027"/>
             </a:xfrm>
             <a:prstGeom prst="rect">
               <a:avLst/>
             </a:prstGeom>
-            <a:noFill/>
-            <a:ln>
-              <a:noFill/>
-            </a:ln>
           </p:spPr>
-          <p:txBody>
-            <a:bodyPr anchorCtr="0" anchor="ctr" bIns="0" lIns="0" spcFirstLastPara="1" rIns="0" wrap="square" tIns="0">
-              <a:noAutofit/>
-            </a:bodyPr>
-            <a:lstStyle/>
-            <a:p>
-              <a:pPr indent="0" lvl="0" marL="0" rtl="0" algn="ctr">
-                <a:spcBef>
-                  <a:spcPts val="0"/>
-                </a:spcBef>
-                <a:spcAft>
-                  <a:spcPts val="0"/>
-                </a:spcAft>
-                <a:buNone/>
-              </a:pPr>
-              <a:r>
-                <a:rPr lang="en" sz="1650">
-                  <a:solidFill>
-                    <a:srgbClr val="7C3AED"/>
-                  </a:solidFill>
-                  <a:latin typeface="Material Icons"/>
-                  <a:ea typeface="Material Icons"/>
-                  <a:cs typeface="Material Icons"/>
-                  <a:sym typeface="Material Icons"/>
-                </a:rPr>
-                <a:t>verified_user</a:t>
-              </a:r>
-              <a:endParaRPr sz="1650">
-                <a:solidFill>
-                  <a:srgbClr val="7C3AED"/>
-                </a:solidFill>
-                <a:latin typeface="Material Icons"/>
-                <a:ea typeface="Material Icons"/>
-                <a:cs typeface="Material Icons"/>
-                <a:sym typeface="Material Icons"/>
-              </a:endParaRPr>
-            </a:p>
-          </p:txBody>
-        </p:sp>
+        </p:pic>
         <p:sp>
           <p:nvSpPr>
             <p:cNvPr id="493" name="Google Shape;493;p22"/>

</xml_diff>